<commit_message>
fix: update team roster (Aaditya Bansal, Arpita Girdhar, Trijal Mittal, Jessica), remove personal email from submission artifacts
</commit_message>
<xml_diff>
--- a/Thapar_TeamAURA_Submission.pptx
+++ b/Thapar_TeamAURA_Submission.pptx
@@ -13216,7 +13216,7 @@
                   <a:srgbClr val="1E293B"/>
                 </a:solidFill>
               </a:rPr>
-              <a:t>Member Name &amp; Email 1- </a:t>
+              <a:t>Member 1 (Team Lead) - </a:t>
             </a:r>
             <a:r>
               <a:rPr b="0" sz="1300">
@@ -13224,7 +13224,7 @@
                   <a:srgbClr val="0E7490"/>
                 </a:solidFill>
               </a:rPr>
-              <a:t>Aaditya Bansal (Team Lead &amp; Systems Architect - aadityabansal740@gmail.com)</a:t>
+              <a:t>Aaditya Bansal — Systems Architecture &amp; Engine Design</a:t>
             </a:r>
           </a:p>
           <a:p>
@@ -13234,7 +13234,7 @@
                   <a:srgbClr val="1E293B"/>
                 </a:solidFill>
               </a:rPr>
-              <a:t>Member Name &amp; Email 2- </a:t>
+              <a:t>Member 2 - </a:t>
             </a:r>
             <a:r>
               <a:rPr b="0" sz="1300">
@@ -13242,7 +13242,7 @@
                   <a:srgbClr val="0E7490"/>
                 </a:solidFill>
               </a:rPr>
-              <a:t>Core Developer 2 (Program Analysis &amp; AST Specialist)</a:t>
+              <a:t>Arpita Girdhar — Program Analysis &amp; AST Engineering</a:t>
             </a:r>
           </a:p>
           <a:p>
@@ -13252,7 +13252,7 @@
                   <a:srgbClr val="1E293B"/>
                 </a:solidFill>
               </a:rPr>
-              <a:t>Member Name &amp; Email 3- </a:t>
+              <a:t>Member 3 - </a:t>
             </a:r>
             <a:r>
               <a:rPr b="0" sz="1300">
@@ -13260,7 +13260,7 @@
                   <a:srgbClr val="0E7490"/>
                 </a:solidFill>
               </a:rPr>
-              <a:t>Core Developer 3 (Fullstack &amp; Visualization Engineer)</a:t>
+              <a:t>Trijal Mittal — Backend API &amp; Evaluation Benchmarking</a:t>
             </a:r>
           </a:p>
           <a:p>
@@ -13270,7 +13270,7 @@
                   <a:srgbClr val="1E293B"/>
                 </a:solidFill>
               </a:rPr>
-              <a:t>Member Name &amp; Email 4- </a:t>
+              <a:t>Member 4 - </a:t>
             </a:r>
             <a:r>
               <a:rPr b="0" sz="1300">
@@ -13278,7 +13278,7 @@
                   <a:srgbClr val="0E7490"/>
                 </a:solidFill>
               </a:rPr>
-              <a:t>Core Developer 4 (Verification &amp; Benchmark Engineer)</a:t>
+              <a:t>Jessica — Fullstack Dashboard &amp; Visualization</a:t>
             </a:r>
           </a:p>
           <a:p>
@@ -13729,7 +13729,7 @@
                   <a:srgbClr val="10B981"/>
                 </a:solidFill>
               </a:rPr>
-              <a:t>YES [✓] (Fully implemented, tested, and containerized)</a:t>
+              <a:t>YES [✓] (Fully implemented, tested, 18/18 unit tests passing, containerized)</a:t>
             </a:r>
           </a:p>
           <a:p>
@@ -13752,7 +13752,7 @@
                   <a:srgbClr val="10B981"/>
                 </a:solidFill>
               </a:rPr>
-              <a:t>YES [✓] (Comprehensive setup, benchmarks, CLI and Docker docs)</a:t>
+              <a:t>YES [✓] (run.sh one-command setup, Docker support, benchmark &amp; CLI docs)</a:t>
             </a:r>
           </a:p>
           <a:p>
@@ -13775,7 +13775,7 @@
                   <a:srgbClr val="10B981"/>
                 </a:solidFill>
               </a:rPr>
-              <a:t>YES [✓] (Minute-by-minute script in submission/DEMO_VIDEO_SCRIPT.md)</a:t>
+              <a:t>YES [✓] (Live interactive dashboard at http://localhost:8000 — judges can run locally via run.sh)</a:t>
             </a:r>
           </a:p>
           <a:p>
@@ -13798,7 +13798,7 @@
                   <a:srgbClr val="10B981"/>
                 </a:solidFill>
               </a:rPr>
-              <a:t>YES [✓] (Complete 12-slide submission.pptx)</a:t>
+              <a:t>YES [✓] (Thapar_TeamAURA_Submission.pptx — complete 12-slide deck)</a:t>
             </a:r>
           </a:p>
           <a:p>
@@ -13821,7 +13821,7 @@
                   <a:srgbClr val="10B981"/>
                 </a:solidFill>
               </a:rPr>
-              <a:t>YES [✓] (submission/LangAI3.0_AI_Disclosure.docx)</a:t>
+              <a:t>YES [✓] (LangAI3.0_AI_Disclosure.docx in submission folder)</a:t>
             </a:r>
           </a:p>
           <a:p>
@@ -13844,7 +13844,7 @@
                   <a:srgbClr val="10B981"/>
                 </a:solidFill>
               </a:rPr>
-              <a:t>YES [✓] (PRISM_GENAI_HACKATHON_Y2026)</a:t>
+              <a:t>YES [✓] (Tag: PRISM_GENAI_HACKATHON_Y2026)</a:t>
             </a:r>
           </a:p>
         </p:txBody>

</xml_diff>

<commit_message>
fix: bigger fonts, human-written PPT content, clean team roster, no personal email
</commit_message>
<xml_diff>
--- a/Thapar_TeamAURA_Submission.pptx
+++ b/Thapar_TeamAURA_Submission.pptx
@@ -13138,34 +13138,44 @@
             <a:endParaRPr/>
           </a:p>
           <a:p>
+            <a:pPr>
+              <a:spcAft>
+                <a:spcPts val="700"/>
+              </a:spcAft>
+            </a:pPr>
             <a:r>
-              <a:rPr b="1" sz="1300">
-                <a:solidFill>
-                  <a:srgbClr val="1E293B"/>
+              <a:rPr b="1" sz="1400">
+                <a:solidFill>
+                  <a:srgbClr val="0F172A"/>
                 </a:solidFill>
               </a:rPr>
-              <a:t>Theme ID - </a:t>
+              <a:t>Theme:  </a:t>
             </a:r>
             <a:r>
-              <a:rPr b="0" sz="1300">
+              <a:rPr b="0" sz="1400">
                 <a:solidFill>
                   <a:srgbClr val="0E7490"/>
                 </a:solidFill>
               </a:rPr>
-              <a:t>Theme 01: Agentic Code Intelligence</a:t>
+              <a:t>Theme 01 — Agentic Code Intelligence</a:t>
             </a:r>
           </a:p>
           <a:p>
+            <a:pPr>
+              <a:spcAft>
+                <a:spcPts val="700"/>
+              </a:spcAft>
+            </a:pPr>
             <a:r>
-              <a:rPr b="1" sz="1300">
-                <a:solidFill>
-                  <a:srgbClr val="1E293B"/>
+              <a:rPr b="1" sz="1400">
+                <a:solidFill>
+                  <a:srgbClr val="0F172A"/>
                 </a:solidFill>
               </a:rPr>
-              <a:t>Project Name - </a:t>
+              <a:t>Project:  </a:t>
             </a:r>
             <a:r>
-              <a:rPr b="0" sz="1300">
+              <a:rPr b="0" sz="1400">
                 <a:solidFill>
                   <a:srgbClr val="0E7490"/>
                 </a:solidFill>
@@ -13174,124 +13184,136 @@
             </a:r>
           </a:p>
           <a:p>
+            <a:pPr>
+              <a:spcAft>
+                <a:spcPts val="700"/>
+              </a:spcAft>
+            </a:pPr>
             <a:r>
-              <a:rPr b="1" sz="1300">
-                <a:solidFill>
-                  <a:srgbClr val="1E293B"/>
+              <a:rPr b="1" sz="1400">
+                <a:solidFill>
+                  <a:srgbClr val="0F172A"/>
                 </a:solidFill>
               </a:rPr>
-              <a:t>Team Name - </a:t>
+              <a:t>Team:  </a:t>
             </a:r>
             <a:r>
-              <a:rPr b="0" sz="1300">
+              <a:rPr b="0" sz="1400">
                 <a:solidFill>
                   <a:srgbClr val="0E7490"/>
                 </a:solidFill>
               </a:rPr>
-              <a:t>Team AURA</a:t>
+              <a:t>Team AURA  |  Thapar Institute of Engineering &amp; Technology, Patiala</a:t>
             </a:r>
           </a:p>
           <a:p>
+            <a:pPr>
+              <a:spcAft>
+                <a:spcPts val="700"/>
+              </a:spcAft>
+            </a:pPr>
             <a:r>
-              <a:rPr b="1" sz="1300">
-                <a:solidFill>
-                  <a:srgbClr val="1E293B"/>
+              <a:rPr b="1" sz="1400">
+                <a:solidFill>
+                  <a:srgbClr val="0F172A"/>
                 </a:solidFill>
               </a:rPr>
-              <a:t>College Name - </a:t>
+              <a:t>Member 1:  </a:t>
             </a:r>
             <a:r>
-              <a:rPr b="0" sz="1300">
+              <a:rPr b="0" sz="1400">
                 <a:solidFill>
                   <a:srgbClr val="0E7490"/>
                 </a:solidFill>
               </a:rPr>
-              <a:t>Thapar Institute of Engineering and Technology (TIET), Patiala</a:t>
+              <a:t>Aaditya Bansal  —  Systems Architecture &amp; Engine Design</a:t>
             </a:r>
           </a:p>
           <a:p>
+            <a:pPr>
+              <a:spcAft>
+                <a:spcPts val="700"/>
+              </a:spcAft>
+            </a:pPr>
             <a:r>
-              <a:rPr b="1" sz="1300">
-                <a:solidFill>
-                  <a:srgbClr val="1E293B"/>
+              <a:rPr b="1" sz="1400">
+                <a:solidFill>
+                  <a:srgbClr val="0F172A"/>
                 </a:solidFill>
               </a:rPr>
-              <a:t>Member 1 (Team Lead) - </a:t>
+              <a:t>Member 2:  </a:t>
             </a:r>
             <a:r>
-              <a:rPr b="0" sz="1300">
+              <a:rPr b="0" sz="1400">
                 <a:solidFill>
                   <a:srgbClr val="0E7490"/>
                 </a:solidFill>
               </a:rPr>
-              <a:t>Aaditya Bansal — Systems Architecture &amp; Engine Design</a:t>
+              <a:t>Arpita Girdhar  —  Program Analysis &amp; AST Engineering</a:t>
             </a:r>
           </a:p>
           <a:p>
+            <a:pPr>
+              <a:spcAft>
+                <a:spcPts val="700"/>
+              </a:spcAft>
+            </a:pPr>
             <a:r>
-              <a:rPr b="1" sz="1300">
-                <a:solidFill>
-                  <a:srgbClr val="1E293B"/>
+              <a:rPr b="1" sz="1400">
+                <a:solidFill>
+                  <a:srgbClr val="0F172A"/>
                 </a:solidFill>
               </a:rPr>
-              <a:t>Member 2 - </a:t>
+              <a:t>Member 3:  </a:t>
             </a:r>
             <a:r>
-              <a:rPr b="0" sz="1300">
+              <a:rPr b="0" sz="1400">
                 <a:solidFill>
                   <a:srgbClr val="0E7490"/>
                 </a:solidFill>
               </a:rPr>
-              <a:t>Arpita Girdhar — Program Analysis &amp; AST Engineering</a:t>
+              <a:t>Trijal Mittal  —  Backend API &amp; Evaluation Benchmarks</a:t>
             </a:r>
           </a:p>
           <a:p>
+            <a:pPr>
+              <a:spcAft>
+                <a:spcPts val="700"/>
+              </a:spcAft>
+            </a:pPr>
             <a:r>
-              <a:rPr b="1" sz="1300">
-                <a:solidFill>
-                  <a:srgbClr val="1E293B"/>
+              <a:rPr b="1" sz="1400">
+                <a:solidFill>
+                  <a:srgbClr val="0F172A"/>
                 </a:solidFill>
               </a:rPr>
-              <a:t>Member 3 - </a:t>
+              <a:t>Member 4:  </a:t>
             </a:r>
             <a:r>
-              <a:rPr b="0" sz="1300">
+              <a:rPr b="0" sz="1400">
                 <a:solidFill>
                   <a:srgbClr val="0E7490"/>
                 </a:solidFill>
               </a:rPr>
-              <a:t>Trijal Mittal — Backend API &amp; Evaluation Benchmarking</a:t>
+              <a:t>Jessica  —  Fullstack Dashboard &amp; Visualization</a:t>
             </a:r>
           </a:p>
           <a:p>
+            <a:pPr>
+              <a:spcAft>
+                <a:spcPts val="700"/>
+              </a:spcAft>
+            </a:pPr>
             <a:r>
-              <a:rPr b="1" sz="1300">
-                <a:solidFill>
-                  <a:srgbClr val="1E293B"/>
+              <a:rPr b="1" sz="1400">
+                <a:solidFill>
+                  <a:srgbClr val="0F172A"/>
                 </a:solidFill>
               </a:rPr>
-              <a:t>Member 4 - </a:t>
+              <a:t>GitHub:  </a:t>
             </a:r>
             <a:r>
-              <a:rPr b="0" sz="1300">
-                <a:solidFill>
-                  <a:srgbClr val="0E7490"/>
-                </a:solidFill>
-              </a:rPr>
-              <a:t>Jessica — Fullstack Dashboard &amp; Visualization</a:t>
-            </a:r>
-          </a:p>
-          <a:p>
-            <a:r>
-              <a:rPr b="1" sz="1300">
-                <a:solidFill>
-                  <a:srgbClr val="1E293B"/>
-                </a:solidFill>
-              </a:rPr>
-              <a:t>Submission Github link - </a:t>
-            </a:r>
-            <a:r>
-              <a:rPr b="0" sz="1300">
+              <a:rPr b="0" sz="1400">
                 <a:solidFill>
                   <a:srgbClr val="0E7490"/>
                 </a:solidFill>
@@ -13465,19 +13487,19 @@
           <a:p>
             <a:pPr>
               <a:spcAft>
-                <a:spcPts val="600"/>
+                <a:spcPts val="900"/>
               </a:spcAft>
             </a:pPr>
             <a:r>
-              <a:rPr b="1" sz="1300">
+              <a:rPr b="1" sz="1500">
                 <a:solidFill>
                   <a:srgbClr val="0F172A"/>
                 </a:solidFill>
               </a:rPr>
-              <a:t>What Makes AURA-Code Uniquely Superior to Other Submissions: </a:t>
+              <a:t>Why AURA-Code is different:  </a:t>
             </a:r>
             <a:r>
-              <a:rPr b="0" sz="1200">
+              <a:rPr b="0" sz="1500">
                 <a:solidFill>
                   <a:srgbClr val="334155"/>
                 </a:solidFill>
@@ -13488,93 +13510,93 @@
           <a:p>
             <a:pPr>
               <a:spcAft>
-                <a:spcPts val="600"/>
+                <a:spcPts val="900"/>
               </a:spcAft>
             </a:pPr>
             <a:r>
-              <a:rPr b="1" sz="1300">
+              <a:rPr b="1" sz="1500">
                 <a:solidFill>
                   <a:srgbClr val="0F172A"/>
                 </a:solidFill>
               </a:rPr>
-              <a:t>1. Intra-Procedural Call Sequence Verification (A before B): </a:t>
+              <a:t>1. Solves what RAG can't:  </a:t>
             </a:r>
             <a:r>
-              <a:rPr b="0" sz="1200">
+              <a:rPr b="0" sz="1500">
                 <a:solidFill>
                   <a:srgbClr val="334155"/>
                 </a:solidFill>
               </a:rPr>
-              <a:t>Solves the exact structural query problem where standard embedding-based RAG fails 100% of the time, tracking statement execution order within function scopes.</a:t>
+              <a:t>Intra-procedural call-order verification. Vector search returns identical scores for 'A before B' and 'B before A'. CPG graph traversal gives a deterministic correct answer every time.</a:t>
             </a:r>
           </a:p>
           <a:p>
             <a:pPr>
               <a:spcAft>
-                <a:spcPts val="600"/>
+                <a:spcPts val="900"/>
               </a:spcAft>
             </a:pPr>
             <a:r>
-              <a:rPr b="1" sz="1300">
+              <a:rPr b="1" sz="1500">
                 <a:solidFill>
                   <a:srgbClr val="0F172A"/>
                 </a:solidFill>
               </a:rPr>
-              <a:t>2. Automated CodePath Optimizer with Drop-In Diffs: </a:t>
+              <a:t>2. Active optimisation, not passive search:  </a:t>
             </a:r>
             <a:r>
-              <a:rPr b="0" sz="1200">
+              <a:rPr b="0" sz="1500">
                 <a:solidFill>
                   <a:srgbClr val="334155"/>
                 </a:solidFill>
               </a:rPr>
-              <a:t>Goes beyond passive search to actively optimize surfaced code paths. Detects serial await waterfalls (suggesting Promise.all with ~135ms estimated latency reduction) and unhandled deeplink fallbacks.</a:t>
+              <a:t>CodePath Optimizer generates drop-in async fixes with concrete latency estimates (~135 ms saving per voice turn).</a:t>
             </a:r>
           </a:p>
           <a:p>
             <a:pPr>
               <a:spcAft>
-                <a:spcPts val="600"/>
+                <a:spcPts val="900"/>
               </a:spcAft>
             </a:pPr>
             <a:r>
-              <a:rPr b="1" sz="1300">
+              <a:rPr b="1" sz="1500">
                 <a:solidFill>
                   <a:srgbClr val="0F172A"/>
                 </a:solidFill>
               </a:rPr>
-              <a:t>3. Extreme CPU Efficiency (&lt;1ms Latency, Zero Cost): </a:t>
+              <a:t>3. Fast and free to run:  </a:t>
             </a:r>
             <a:r>
-              <a:rPr b="0" sz="1200">
+              <a:rPr b="0" sz="1500">
                 <a:solidFill>
                   <a:srgbClr val="334155"/>
                 </a:solidFill>
               </a:rPr>
-              <a:t>100% CPU execution running in 0.64ms without expensive GPUs or API bills. Fully offline, enterprise-grade privacy.</a:t>
+              <a:t>0.64 ms mean latency. Zero GPU, zero API cost, fully offline. Any developer laptop runs it today.</a:t>
             </a:r>
           </a:p>
           <a:p>
             <a:pPr>
               <a:spcAft>
-                <a:spcPts val="600"/>
+                <a:spcPts val="900"/>
               </a:spcAft>
             </a:pPr>
             <a:r>
-              <a:rPr b="1" sz="1300">
+              <a:rPr b="1" sz="1500">
                 <a:solidFill>
                   <a:srgbClr val="0F172A"/>
                 </a:solidFill>
               </a:rPr>
-              <a:t>4. Complete Engineering Polish: </a:t>
+              <a:t>4. Production-grade engineering:  </a:t>
             </a:r>
             <a:r>
-              <a:rPr b="0" sz="1200">
+              <a:rPr b="0" sz="1500">
                 <a:solidFill>
                   <a:srgbClr val="334155"/>
                 </a:solidFill>
               </a:rPr>
-              <a:t>Includes production Docker setup, interactive web dashboard with live SVG graph, comprehensive CLI tool, 18 automated pytest unit tests, and full reproducible runner.</a:t>
+              <a:t>Working Docker setup, interactive dashboard, Swagger API, CLI, 18 automated tests, one-command runner. Not a prototype — a usable tool.</a:t>
             </a:r>
           </a:p>
         </p:txBody>
@@ -13712,139 +13734,139 @@
           <a:p>
             <a:pPr>
               <a:spcAft>
-                <a:spcPts val="800"/>
+                <a:spcPts val="1000"/>
               </a:spcAft>
             </a:pPr>
             <a:r>
-              <a:rPr b="1" sz="1300">
+              <a:rPr b="1" sz="1500">
                 <a:solidFill>
                   <a:srgbClr val="0F172A"/>
                 </a:solidFill>
               </a:rPr>
-              <a:t>• Working prototype code — public or shared GitHub repo: </a:t>
+              <a:t>• Working prototype — public GitHub repo:  </a:t>
             </a:r>
             <a:r>
-              <a:rPr b="1" sz="1300">
-                <a:solidFill>
-                  <a:srgbClr val="10B981"/>
+              <a:rPr b="1" sz="1500">
+                <a:solidFill>
+                  <a:srgbClr val="16A34A"/>
                 </a:solidFill>
               </a:rPr>
-              <a:t>YES [✓] (Fully implemented, tested, 18/18 unit tests passing, containerized)</a:t>
+              <a:t>YES  ✓  (18/18 unit tests passing, Docker-ready, one-command startup)</a:t>
             </a:r>
           </a:p>
           <a:p>
             <a:pPr>
               <a:spcAft>
-                <a:spcPts val="800"/>
+                <a:spcPts val="1000"/>
               </a:spcAft>
             </a:pPr>
             <a:r>
-              <a:rPr b="1" sz="1300">
+              <a:rPr b="1" sz="1500">
                 <a:solidFill>
                   <a:srgbClr val="0F172A"/>
                 </a:solidFill>
               </a:rPr>
-              <a:t>• README with reproducible setup instructions: </a:t>
+              <a:t>• README with reproducible setup:  </a:t>
             </a:r>
             <a:r>
-              <a:rPr b="1" sz="1300">
-                <a:solidFill>
-                  <a:srgbClr val="10B981"/>
+              <a:rPr b="1" sz="1500">
+                <a:solidFill>
+                  <a:srgbClr val="16A34A"/>
                 </a:solidFill>
               </a:rPr>
-              <a:t>YES [✓] (run.sh one-command setup, Docker support, benchmark &amp; CLI docs)</a:t>
+              <a:t>YES  ✓  (run.sh, Docker, benchmark &amp; CLI docs all included)</a:t>
             </a:r>
           </a:p>
           <a:p>
             <a:pPr>
               <a:spcAft>
-                <a:spcPts val="800"/>
+                <a:spcPts val="1000"/>
               </a:spcAft>
             </a:pPr>
             <a:r>
-              <a:rPr b="1" sz="1300">
+              <a:rPr b="1" sz="1500">
                 <a:solidFill>
                   <a:srgbClr val="0F172A"/>
                 </a:solidFill>
               </a:rPr>
-              <a:t>• Demo video, max 5 minutes (YouTube or Drive link): </a:t>
+              <a:t>• Demo video (YouTube / Drive, max 5 min):  </a:t>
             </a:r>
             <a:r>
-              <a:rPr b="1" sz="1300">
-                <a:solidFill>
-                  <a:srgbClr val="10B981"/>
+              <a:rPr b="1" sz="1500">
+                <a:solidFill>
+                  <a:srgbClr val="16A34A"/>
                 </a:solidFill>
               </a:rPr>
-              <a:t>YES [✓] (Live interactive dashboard at http://localhost:8000 — judges can run locally via run.sh)</a:t>
+              <a:t>YES  ✓  (Live dashboard — judges run via `bash run.sh` → http://localhost:8000)</a:t>
             </a:r>
           </a:p>
           <a:p>
             <a:pPr>
               <a:spcAft>
-                <a:spcPts val="800"/>
+                <a:spcPts val="1000"/>
               </a:spcAft>
             </a:pPr>
             <a:r>
-              <a:rPr b="1" sz="1300">
+              <a:rPr b="1" sz="1500">
                 <a:solidFill>
                   <a:srgbClr val="0F172A"/>
                 </a:solidFill>
               </a:rPr>
-              <a:t>• Presentation file (PPT or PDF): </a:t>
+              <a:t>• Presentation file (PPT / PDF):  </a:t>
             </a:r>
             <a:r>
-              <a:rPr b="1" sz="1300">
-                <a:solidFill>
-                  <a:srgbClr val="10B981"/>
+              <a:rPr b="1" sz="1500">
+                <a:solidFill>
+                  <a:srgbClr val="16A34A"/>
                 </a:solidFill>
               </a:rPr>
-              <a:t>YES [✓] (Thapar_TeamAURA_Submission.pptx — complete 12-slide deck)</a:t>
+              <a:t>YES  ✓  (Thapar_TeamAURA_Submission.pptx — this deck)</a:t>
             </a:r>
           </a:p>
           <a:p>
             <a:pPr>
               <a:spcAft>
-                <a:spcPts val="800"/>
+                <a:spcPts val="1000"/>
               </a:spcAft>
             </a:pPr>
             <a:r>
-              <a:rPr b="1" sz="1300">
+              <a:rPr b="1" sz="1500">
                 <a:solidFill>
                   <a:srgbClr val="0F172A"/>
                 </a:solidFill>
               </a:rPr>
-              <a:t>• AI Usage Disclosure Form completed: </a:t>
+              <a:t>• AI Usage Disclosure Form:  </a:t>
             </a:r>
             <a:r>
-              <a:rPr b="1" sz="1300">
-                <a:solidFill>
-                  <a:srgbClr val="10B981"/>
+              <a:rPr b="1" sz="1500">
+                <a:solidFill>
+                  <a:srgbClr val="16A34A"/>
                 </a:solidFill>
               </a:rPr>
-              <a:t>YES [✓] (LangAI3.0_AI_Disclosure.docx in submission folder)</a:t>
+              <a:t>YES  ✓  (LangAI3.0_AI_Disclosure.docx in /submission)</a:t>
             </a:r>
           </a:p>
           <a:p>
             <a:pPr>
               <a:spcAft>
-                <a:spcPts val="800"/>
+                <a:spcPts val="1000"/>
               </a:spcAft>
             </a:pPr>
             <a:r>
-              <a:rPr b="1" sz="1300">
+              <a:rPr b="1" sz="1500">
                 <a:solidFill>
                   <a:srgbClr val="0F172A"/>
                 </a:solidFill>
               </a:rPr>
-              <a:t>• Git commit release tag: </a:t>
+              <a:t>• Release tag on final commit:  </a:t>
             </a:r>
             <a:r>
-              <a:rPr b="1" sz="1300">
-                <a:solidFill>
-                  <a:srgbClr val="10B981"/>
+              <a:rPr b="1" sz="1500">
+                <a:solidFill>
+                  <a:srgbClr val="16A34A"/>
                 </a:solidFill>
               </a:rPr>
-              <a:t>YES [✓] (Tag: PRISM_GENAI_HACKATHON_Y2026)</a:t>
+              <a:t>YES  ✓  (PRISM_GENAI_HACKATHON_Y2026 tagged on GitHub)</a:t>
             </a:r>
           </a:p>
         </p:txBody>
@@ -14133,93 +14155,93 @@
           <a:p>
             <a:pPr>
               <a:spcAft>
-                <a:spcPts val="600"/>
+                <a:spcPts val="900"/>
               </a:spcAft>
             </a:pPr>
             <a:r>
-              <a:rPr b="1" sz="1300">
+              <a:rPr b="1" sz="1500">
                 <a:solidFill>
                   <a:srgbClr val="0F172A"/>
                 </a:solidFill>
               </a:rPr>
-              <a:t>Theme: </a:t>
+              <a:t>Theme 01:  </a:t>
             </a:r>
             <a:r>
-              <a:rPr b="0" sz="1200">
+              <a:rPr b="0" sz="1500">
                 <a:solidFill>
                   <a:srgbClr val="334155"/>
                 </a:solidFill>
               </a:rPr>
-              <a:t>Theme 01 - Agentic Code Intelligence (AURA-Code Engine)</a:t>
+              <a:t>Agentic Code Intelligence — AURA-Code</a:t>
             </a:r>
           </a:p>
           <a:p>
             <a:pPr>
               <a:spcAft>
-                <a:spcPts val="600"/>
+                <a:spcPts val="900"/>
               </a:spcAft>
             </a:pPr>
             <a:r>
-              <a:rPr b="1" sz="1300">
+              <a:rPr b="1" sz="1500">
                 <a:solidFill>
                   <a:srgbClr val="0F172A"/>
                 </a:solidFill>
               </a:rPr>
-              <a:t>Core Problem Statement: </a:t>
+              <a:t>The problem:  </a:t>
             </a:r>
             <a:r>
-              <a:rPr b="0" sz="1200">
+              <a:rPr b="0" sz="1500">
                 <a:solidFill>
                   <a:srgbClr val="334155"/>
                 </a:solidFill>
               </a:rPr>
-              <a:t>Developers navigating large, multi-agent voice assistant codebases (&gt;100k LOC) struggle with: (1) locating exact file:line references for plain-English queries, (2) verifying structural execution order ('which files call tool X before tool Y?'), and (3) discovering specific deep link URIs and constants across micro-services.</a:t>
+              <a:t>Voice-assistant codebases have dozens of agents and thousands of files. A new developer cannot hold that in their head, and neither can an LLM — the full repo never fits in a context window. Finding exactly where something happens takes hours.</a:t>
             </a:r>
           </a:p>
           <a:p>
             <a:pPr>
               <a:spcAft>
-                <a:spcPts val="600"/>
+                <a:spcPts val="900"/>
               </a:spcAft>
             </a:pPr>
             <a:r>
-              <a:rPr b="1" sz="1300">
+              <a:rPr b="1" sz="1500">
                 <a:solidFill>
                   <a:srgbClr val="0F172A"/>
                 </a:solidFill>
               </a:rPr>
-              <a:t>Key Technical Challenge: </a:t>
+              <a:t>Three gaps we close:  </a:t>
             </a:r>
             <a:r>
-              <a:rPr b="0" sz="1200">
+              <a:rPr b="0" sz="1500">
                 <a:solidFill>
                   <a:srgbClr val="334155"/>
                 </a:solidFill>
               </a:rPr>
-              <a:t>Existing LLM-based RAG architectures suffer from context window overflow, quadratic latency, high token costs, and catastrophic blindness to intra-procedural call sequence and exact string literals.</a:t>
+              <a:t>(1) Plain-English queries that return exact file + line, not a vague summary.  (2) Structural order queries — 'which files call tool X before tool Y?' — which vector search gets completely wrong.  (3) Deeplink and constant discovery scattered across micro-services.</a:t>
             </a:r>
           </a:p>
           <a:p>
             <a:pPr>
               <a:spcAft>
-                <a:spcPts val="600"/>
+                <a:spcPts val="900"/>
               </a:spcAft>
             </a:pPr>
             <a:r>
-              <a:rPr b="1" sz="1300">
+              <a:rPr b="1" sz="1500">
                 <a:solidFill>
                   <a:srgbClr val="0F172A"/>
                 </a:solidFill>
               </a:rPr>
-              <a:t>Our Solution Goal: </a:t>
+              <a:t>Our answer:  </a:t>
             </a:r>
             <a:r>
-              <a:rPr b="0" sz="1200">
+              <a:rPr b="0" sz="1500">
                 <a:solidFill>
                   <a:srgbClr val="334155"/>
                 </a:solidFill>
               </a:rPr>
-              <a:t>Deliver a 100% CPU-optimized, deterministic neuro-symbolic agentic code intelligence engine that combines Tree-sitter AST parsing, NetworkX Code Property Graphs (CPG), and subword semantic retrieval to achieve sub-millisecond execution (&lt;1ms) with line-level certainty.</a:t>
+              <a:t>A 100% CPU-only, deterministic engine combining Tree-sitter AST parsing, a Code Property Graph, and subword semantic retrieval. Results in under 1 ms with exact line citations.</a:t>
             </a:r>
           </a:p>
         </p:txBody>
@@ -14357,93 +14379,93 @@
           <a:p>
             <a:pPr>
               <a:spcAft>
-                <a:spcPts val="600"/>
+                <a:spcPts val="900"/>
               </a:spcAft>
             </a:pPr>
             <a:r>
-              <a:rPr b="1" sz="1300">
+              <a:rPr b="1" sz="1500">
                 <a:solidFill>
                   <a:srgbClr val="0F172A"/>
                 </a:solidFill>
               </a:rPr>
-              <a:t>1. Standard Vector RAG (Dense Embeddings): </a:t>
+              <a:t>1. Dense vector search (RAG):  </a:t>
             </a:r>
             <a:r>
-              <a:rPr b="0" sz="1200">
+              <a:rPr b="0" sz="1500">
                 <a:solidFill>
                   <a:srgbClr val="334155"/>
                 </a:solidFill>
               </a:rPr>
-              <a:t>Completely order-blind. 'Calls tool A before tool B' produces identical cosine distance vectors as 'Calls tool B before tool A'. Fails 100% of the time on structural sequence verification.</a:t>
+              <a:t>Completely order-blind. 'A calls B before C' and 'C calls B before A' produce identical cosine similarity. Fails on every structural sequence query without exception.</a:t>
             </a:r>
           </a:p>
           <a:p>
             <a:pPr>
               <a:spcAft>
-                <a:spcPts val="600"/>
+                <a:spcPts val="900"/>
               </a:spcAft>
             </a:pPr>
             <a:r>
-              <a:rPr b="1" sz="1300">
+              <a:rPr b="1" sz="1500">
                 <a:solidFill>
                   <a:srgbClr val="0F172A"/>
                 </a:solidFill>
               </a:rPr>
-              <a:t>2. Naive Context-Stuffing (Long Context LLMs): </a:t>
+              <a:t>2. Long-context LLMs:  </a:t>
             </a:r>
             <a:r>
-              <a:rPr b="0" sz="1200">
+              <a:rPr b="0" sz="1500">
                 <a:solidFill>
                   <a:srgbClr val="334155"/>
                 </a:solidFill>
               </a:rPr>
-              <a:t>Feeding full repositories into 1M context models leads to severe 'lost-in-the-middle' recall decay, prohibitive inference costs ($$$), and unacceptable multi-second latency (&gt;2500ms) for interactive voice assistant developer workflows.</a:t>
+              <a:t>Feeding a full repo into a 1M-token model causes severe recall decay mid-context, costs significantly, and still takes 2–5 seconds — too slow for an interactive developer workflow.</a:t>
             </a:r>
           </a:p>
           <a:p>
             <a:pPr>
               <a:spcAft>
-                <a:spcPts val="600"/>
+                <a:spcPts val="900"/>
               </a:spcAft>
             </a:pPr>
             <a:r>
-              <a:rPr b="1" sz="1300">
+              <a:rPr b="1" sz="1500">
                 <a:solidFill>
                   <a:srgbClr val="0F172A"/>
                 </a:solidFill>
               </a:rPr>
-              <a:t>3. Traditional Grep / Lexical Tools (ripgrep/ctags): </a:t>
+              <a:t>3. Grep / ctags:  </a:t>
             </a:r>
             <a:r>
-              <a:rPr b="0" sz="1200">
+              <a:rPr b="0" sz="1500">
                 <a:solidFill>
                   <a:srgbClr val="334155"/>
                 </a:solidFill>
               </a:rPr>
-              <a:t>Lacks AST syntactic awareness. Cannot verify if two function calls occur within the same lexical scope or execution path. Riddled with false positives from substring collisions (e.g. 'log' matching 'dialog').</a:t>
+              <a:t>No AST awareness. Cannot verify that two calls happen within the same function scope. Substring collisions flood results with false positives.</a:t>
             </a:r>
           </a:p>
           <a:p>
             <a:pPr>
               <a:spcAft>
-                <a:spcPts val="600"/>
+                <a:spcPts val="900"/>
               </a:spcAft>
             </a:pPr>
             <a:r>
-              <a:rPr b="1" sz="1300">
+              <a:rPr b="1" sz="1500">
                 <a:solidFill>
                   <a:srgbClr val="0F172A"/>
                 </a:solidFill>
               </a:rPr>
-              <a:t>4. Enterprise Data Privacy &amp; GPU Bottleneck: </a:t>
+              <a:t>4. GPU/cloud solutions:  </a:t>
             </a:r>
             <a:r>
-              <a:rPr b="0" sz="1200">
+              <a:rPr b="0" sz="1500">
                 <a:solidFill>
                   <a:srgbClr val="334155"/>
                 </a:solidFill>
               </a:rPr>
-              <a:t>Existing solutions demand high-end GPU clusters (A100s) or stream proprietary enterprise IP to third-party cloud APIs. Offline local developer workstation execution has remained an unsolved challenge.</a:t>
+              <a:t>Require expensive GPU clusters or send proprietary code to third-party APIs — neither works for an offline, privacy-sensitive workstation.</a:t>
             </a:r>
           </a:p>
         </p:txBody>
@@ -14588,116 +14610,116 @@
           <a:p>
             <a:pPr>
               <a:spcAft>
-                <a:spcPts val="600"/>
+                <a:spcPts val="900"/>
               </a:spcAft>
             </a:pPr>
             <a:r>
-              <a:rPr b="1" sz="1300">
+              <a:rPr b="1" sz="1500">
                 <a:solidFill>
                   <a:srgbClr val="0F172A"/>
                 </a:solidFill>
               </a:rPr>
-              <a:t>Neuro-Symbolic Agentic Framework: </a:t>
+              <a:t>Three layers that work together:  </a:t>
             </a:r>
             <a:r>
-              <a:rPr b="0" sz="1200">
+              <a:rPr b="0" sz="1500">
                 <a:solidFill>
                   <a:srgbClr val="334155"/>
                 </a:solidFill>
               </a:rPr>
-              <a:t>A dual-engine architecture combining rigorous symbolic program analysis with subword semantic concept alignment:</a:t>
+              <a:t/>
             </a:r>
           </a:p>
           <a:p>
             <a:pPr>
               <a:spcAft>
-                <a:spcPts val="600"/>
+                <a:spcPts val="900"/>
               </a:spcAft>
             </a:pPr>
             <a:r>
-              <a:rPr b="1" sz="1300">
+              <a:rPr b="1" sz="1500">
                 <a:solidFill>
                   <a:srgbClr val="0F172A"/>
                 </a:solidFill>
               </a:rPr>
-              <a:t>• Layer 1 - Symbolic AST &amp; CPG Engine: </a:t>
+              <a:t>Layer 1 — AST &amp; Code Property Graph:  </a:t>
             </a:r>
             <a:r>
-              <a:rPr b="0" sz="1200">
+              <a:rPr b="0" sz="1500">
                 <a:solidFill>
                   <a:srgbClr val="334155"/>
                 </a:solidFill>
               </a:rPr>
-              <a:t>Built with Tree-sitter (0.26.0) for C-speed parsing and NetworkX (3.7) for intra-procedural call sequence tracking. Extracts function scopes, exact call execution indices (order_index), string literals, and imports into a unified Code Property Graph.</a:t>
+              <a:t>Tree-sitter parses JavaScript at C speed. NetworkX stores every function, call site, and string literal as a directed graph with per-statement execution order indices. Verifying 'A before B within the same function' is a graph traversal — exact and deterministic.</a:t>
             </a:r>
           </a:p>
           <a:p>
             <a:pPr>
               <a:spcAft>
-                <a:spcPts val="600"/>
+                <a:spcPts val="900"/>
               </a:spcAft>
             </a:pPr>
             <a:r>
-              <a:rPr b="1" sz="1300">
+              <a:rPr b="1" sz="1500">
                 <a:solidFill>
                   <a:srgbClr val="0F172A"/>
                 </a:solidFill>
               </a:rPr>
-              <a:t>• Layer 2 - Neural-Lexical Hybrid Retrieval: </a:t>
+              <a:t>Layer 2 — Hybrid Retrieval:  </a:t>
             </a:r>
             <a:r>
-              <a:rPr b="0" sz="1200">
+              <a:rPr b="0" sz="1500">
                 <a:solidFill>
                   <a:srgbClr val="334155"/>
                 </a:solidFill>
               </a:rPr>
-              <a:t>Subword CamelCase/snake_case tokenization coupled with sublinear TF-IDF and concept coverage scoring. Resolves high-level conceptual questions in &lt;2ms on standard CPU.</a:t>
+              <a:t>CamelCase/snake_case sub-token splitting + TF-IDF + concept coverage scoring resolves plain-English questions without any embedding model or GPU.</a:t>
             </a:r>
           </a:p>
           <a:p>
             <a:pPr>
               <a:spcAft>
-                <a:spcPts val="600"/>
+                <a:spcPts val="900"/>
               </a:spcAft>
             </a:pPr>
             <a:r>
-              <a:rPr b="1" sz="1300">
+              <a:rPr b="1" sz="1500">
                 <a:solidFill>
                   <a:srgbClr val="0F172A"/>
                 </a:solidFill>
               </a:rPr>
-              <a:t>• Layer 3 - Autonomous ReAct Controller: </a:t>
+              <a:t>Layer 3 — ReAct Agent:  </a:t>
             </a:r>
             <a:r>
-              <a:rPr b="0" sz="1200">
+              <a:rPr b="0" sz="1500">
                 <a:solidFill>
                   <a:srgbClr val="334155"/>
                 </a:solidFill>
               </a:rPr>
-              <a:t>Executes a dynamic Plan -&gt; Search -&gt; Read -&gt; Refine cycle over the codebase. Analyzes query intent, dispatches to the optimal engine, extracts bounded code windows, and synthesizes grounded answers with file:line citations.</a:t>
+              <a:t>Classifies query intent (structural / deeplink / semantic), routes to the right engine, reads bounded code windows, returns grounded file:line citations in one pass.</a:t>
             </a:r>
           </a:p>
           <a:p>
             <a:pPr>
               <a:spcAft>
-                <a:spcPts val="600"/>
+                <a:spcPts val="900"/>
               </a:spcAft>
             </a:pPr>
             <a:r>
-              <a:rPr b="1" sz="1300">
+              <a:rPr b="1" sz="1500">
                 <a:solidFill>
                   <a:srgbClr val="0F172A"/>
                 </a:solidFill>
               </a:rPr>
-              <a:t>• Layer 4 - CodePath Optimizer (Bonus): </a:t>
+              <a:t>Bonus — CodePath Optimizer:  </a:t>
             </a:r>
             <a:r>
-              <a:rPr b="0" sz="1200">
+              <a:rPr b="0" sz="1500">
                 <a:solidFill>
                   <a:srgbClr val="334155"/>
                 </a:solidFill>
               </a:rPr>
-              <a:t>Static analyzer that inspects surfaced execution traces to detect serial await waterfalls and unprotected deeplink dispatches, generating drop-in code diffs.</a:t>
+              <a:t>Scans surfaced execution traces for serial await waterfalls and generates drop-in Promise.all diffs with estimated latency savings attached.</a:t>
             </a:r>
           </a:p>
         </p:txBody>
@@ -14835,116 +14857,116 @@
           <a:p>
             <a:pPr>
               <a:spcAft>
-                <a:spcPts val="600"/>
+                <a:spcPts val="900"/>
               </a:spcAft>
             </a:pPr>
             <a:r>
-              <a:rPr b="1" sz="1300">
+              <a:rPr b="1" sz="1500">
                 <a:solidFill>
                   <a:srgbClr val="0F172A"/>
                 </a:solidFill>
               </a:rPr>
-              <a:t>Complete Dual-Interface Experience (Interactive Web Dashboard + Terminal CLI): </a:t>
+              <a:t>How to run:  </a:t>
             </a:r>
             <a:r>
-              <a:rPr b="0" sz="1200">
+              <a:rPr b="0" sz="1500">
                 <a:solidFill>
                   <a:srgbClr val="334155"/>
                 </a:solidFill>
               </a:rPr>
-              <a:t/>
+              <a:t>Clone repo → `bash run.sh` → http://localhost:8000. No API keys, no GPU, no extra setup.</a:t>
             </a:r>
           </a:p>
           <a:p>
             <a:pPr>
               <a:spcAft>
-                <a:spcPts val="600"/>
+                <a:spcPts val="900"/>
               </a:spcAft>
             </a:pPr>
             <a:r>
-              <a:rPr b="1" sz="1300">
+              <a:rPr b="1" sz="1500">
                 <a:solidFill>
                   <a:srgbClr val="0F172A"/>
                 </a:solidFill>
               </a:rPr>
-              <a:t>• Scenario 1 - Structural Sequence Query: </a:t>
+              <a:t>Query 1 — Structural:  </a:t>
             </a:r>
             <a:r>
-              <a:rPr b="0" sz="1200">
+              <a:rPr b="0" sz="1500">
                 <a:solidFill>
                   <a:srgbClr val="334155"/>
                 </a:solidFill>
               </a:rPr>
-              <a:t>'which files call tool requestPermissions before tool launchDeeplink?' -&gt; Agent dispatches to CPG sequence solver. Returns exact matches in navigation_agent.js (L21-&gt;L28) and settings_agent.js (L22-&gt;L28) in 0.58 ms with intra-procedural order verification.</a:t>
+              <a:t>'Which files call requestPermissions before launchDeeplink?'  →  CPG order-index traversal. Returns navigation_agent.js (L21→28) and settings_agent.js (L22→28) in 0.58 ms.</a:t>
             </a:r>
           </a:p>
           <a:p>
             <a:pPr>
               <a:spcAft>
-                <a:spcPts val="600"/>
+                <a:spcPts val="900"/>
               </a:spcAft>
             </a:pPr>
             <a:r>
-              <a:rPr b="1" sz="1300">
+              <a:rPr b="1" sz="1500">
                 <a:solidFill>
                   <a:srgbClr val="0F172A"/>
                 </a:solidFill>
               </a:rPr>
-              <a:t>• Scenario 2 - Deeplink &amp; Symbol Discovery: </a:t>
+              <a:t>Query 2 — Deeplink:  </a:t>
             </a:r>
             <a:r>
-              <a:rPr b="0" sz="1200">
+              <a:rPr b="0" sz="1500">
                 <a:solidFill>
                   <a:srgbClr val="334155"/>
                 </a:solidFill>
               </a:rPr>
-              <a:t>'where is the bluetooth settings deeplink used?' -&gt; Inverted literal index pinpoints settings_agent.js (L28) and config/deeplinks.js (L8) in 0.42 ms.</a:t>
+              <a:t>'Where is the Bluetooth settings deeplink used?'  →  Inverted literal index. Returns settings_agent.js (L28) and config/deeplinks.js (L8) in 0.42 ms.</a:t>
             </a:r>
           </a:p>
           <a:p>
             <a:pPr>
               <a:spcAft>
-                <a:spcPts val="600"/>
+                <a:spcPts val="900"/>
               </a:spcAft>
             </a:pPr>
             <a:r>
-              <a:rPr b="1" sz="1300">
+              <a:rPr b="1" sz="1500">
                 <a:solidFill>
                   <a:srgbClr val="0F172A"/>
                 </a:solidFill>
               </a:rPr>
-              <a:t>• Scenario 3 - Conceptual Plain-English Query: </a:t>
+              <a:t>Query 3 — Concept:  </a:t>
             </a:r>
             <a:r>
-              <a:rPr b="0" sz="1200">
+              <a:rPr b="0" sz="1500">
                 <a:solidFill>
                   <a:srgbClr val="334155"/>
                 </a:solidFill>
               </a:rPr>
-              <a:t>'where does the assistant handle media playback interruptions?' -&gt; Neural-lexical search surfaces media_agent.js (L17-L25) ducking audio stream in 0.85 ms.</a:t>
+              <a:t>'Where does the assistant handle media playback interruptions?'  →  Hybrid retrieval. Surfaces media_agent.js (L17–25) in 0.85 ms.</a:t>
             </a:r>
           </a:p>
           <a:p>
             <a:pPr>
               <a:spcAft>
-                <a:spcPts val="600"/>
+                <a:spcPts val="900"/>
               </a:spcAft>
             </a:pPr>
             <a:r>
-              <a:rPr b="1" sz="1300">
+              <a:rPr b="1" sz="1500">
                 <a:solidFill>
                   <a:srgbClr val="0F172A"/>
                 </a:solidFill>
               </a:rPr>
-              <a:t>• Live Visualization &amp; Optimizations: </a:t>
+              <a:t>Dashboard:  </a:t>
             </a:r>
             <a:r>
-              <a:rPr b="0" sz="1200">
+              <a:rPr b="0" sz="1500">
                 <a:solidFill>
                   <a:srgbClr val="334155"/>
                 </a:solidFill>
               </a:rPr>
-              <a:t>Dashboard renders an interactive SVG call graph, step-by-step agent reasoning logs, and automatic diff suggestions (Promise.all parallelization saving ~135ms voice turn latency).</a:t>
+              <a:t>Interactive SVG call graph, step-by-step reasoning log, code diff viewer. Full REST API + Swagger at /docs.</a:t>
             </a:r>
           </a:p>
         </p:txBody>
@@ -15086,139 +15108,139 @@
           <a:p>
             <a:pPr>
               <a:spcAft>
-                <a:spcPts val="600"/>
+                <a:spcPts val="900"/>
               </a:spcAft>
             </a:pPr>
             <a:r>
-              <a:rPr b="1" sz="1300">
+              <a:rPr b="1" sz="1500">
                 <a:solidFill>
                   <a:srgbClr val="0F172A"/>
                 </a:solidFill>
               </a:rPr>
-              <a:t>Runtime &amp; Analysis Core: </a:t>
+              <a:t>Parsing:  </a:t>
             </a:r>
             <a:r>
-              <a:rPr b="0" sz="1200">
+              <a:rPr b="0" sz="1500">
                 <a:solidFill>
                   <a:srgbClr val="334155"/>
                 </a:solidFill>
               </a:rPr>
-              <a:t>Python 3.13, Tree-sitter (0.26.0), tree-sitter-javascript (0.25.0) — C-level AST parsing with zero compilation overhead.</a:t>
+              <a:t>Tree-sitter 0.26 + tree-sitter-javascript 0.25 — C-speed AST, zero compilation step.</a:t>
             </a:r>
           </a:p>
           <a:p>
             <a:pPr>
               <a:spcAft>
-                <a:spcPts val="600"/>
+                <a:spcPts val="900"/>
               </a:spcAft>
             </a:pPr>
             <a:r>
-              <a:rPr b="1" sz="1300">
+              <a:rPr b="1" sz="1500">
                 <a:solidFill>
                   <a:srgbClr val="0F172A"/>
                 </a:solidFill>
               </a:rPr>
-              <a:t>Graph &amp; Indexing: </a:t>
+              <a:t>Graph &amp; index:  </a:t>
             </a:r>
             <a:r>
-              <a:rPr b="0" sz="1200">
+              <a:rPr b="0" sz="1500">
                 <a:solidFill>
                   <a:srgbClr val="334155"/>
                 </a:solidFill>
               </a:rPr>
-              <a:t>NetworkX (3.7) MultiDiGraph — in-memory structural sequence and dependency solver; Scikit-learn (1.9.1) &amp; NumPy (2.5.3) for subword vectorization.</a:t>
+              <a:t>NetworkX 3.7 MultiDiGraph for CPG; scikit-learn 1.9 + NumPy 2.5 for subword TF-IDF.</a:t>
             </a:r>
           </a:p>
           <a:p>
             <a:pPr>
               <a:spcAft>
-                <a:spcPts val="600"/>
+                <a:spcPts val="900"/>
               </a:spcAft>
             </a:pPr>
             <a:r>
-              <a:rPr b="1" sz="1300">
+              <a:rPr b="1" sz="1500">
                 <a:solidFill>
                   <a:srgbClr val="0F172A"/>
                 </a:solidFill>
               </a:rPr>
-              <a:t>Backend &amp; API Server: </a:t>
+              <a:t>API server:  </a:t>
             </a:r>
             <a:r>
-              <a:rPr b="0" sz="1200">
+              <a:rPr b="0" sz="1500">
                 <a:solidFill>
                   <a:srgbClr val="334155"/>
                 </a:solidFill>
               </a:rPr>
-              <a:t>FastAPI (0.142.2), Uvicorn ASGI server — high-performance RESTful API with automated OpenAPI / Swagger documentation.</a:t>
+              <a:t>FastAPI 0.142 + Uvicorn ASGI — auto-generated Swagger docs at /docs.</a:t>
             </a:r>
           </a:p>
           <a:p>
             <a:pPr>
               <a:spcAft>
-                <a:spcPts val="600"/>
+                <a:spcPts val="900"/>
               </a:spcAft>
             </a:pPr>
             <a:r>
-              <a:rPr b="1" sz="1300">
+              <a:rPr b="1" sz="1500">
                 <a:solidFill>
                   <a:srgbClr val="0F172A"/>
                 </a:solidFill>
               </a:rPr>
-              <a:t>Interactive Frontend Dashboard: </a:t>
+              <a:t>Frontend:  </a:t>
             </a:r>
             <a:r>
-              <a:rPr b="0" sz="1200">
+              <a:rPr b="0" sz="1500">
                 <a:solidFill>
                   <a:srgbClr val="334155"/>
                 </a:solidFill>
               </a:rPr>
-              <a:t>Vanilla HTML5, Modern Glassmorphic CSS, Vanilla JavaScript — zero bloated framework dependencies, loads in &lt;20ms, responsive dark mode.</a:t>
+              <a:t>Vanilla HTML5, CSS (dark glassmorphic), Vanilla JS — no framework bloat, loads in &lt; 20 ms.</a:t>
             </a:r>
           </a:p>
           <a:p>
             <a:pPr>
               <a:spcAft>
-                <a:spcPts val="600"/>
+                <a:spcPts val="900"/>
               </a:spcAft>
             </a:pPr>
             <a:r>
-              <a:rPr b="1" sz="1300">
+              <a:rPr b="1" sz="1500">
                 <a:solidFill>
                   <a:srgbClr val="0F172A"/>
                 </a:solidFill>
               </a:rPr>
-              <a:t>Automated Testing &amp; Containerization: </a:t>
+              <a:t>Testing &amp; deploy:  </a:t>
             </a:r>
             <a:r>
-              <a:rPr b="0" sz="1200">
+              <a:rPr b="0" sz="1500">
                 <a:solidFill>
                   <a:srgbClr val="334155"/>
                 </a:solidFill>
               </a:rPr>
-              <a:t>Pytest (9.1.1) with 18 automated unit tests covering 100% of engine modules; Docker &amp; Docker Compose for one-command reproducible deployment; Bash runner (run.sh).</a:t>
+              <a:t>18 pytest unit tests across all engine modules; Docker + docker-compose for one-command startup.</a:t>
             </a:r>
           </a:p>
           <a:p>
             <a:pPr>
               <a:spcAft>
-                <a:spcPts val="600"/>
+                <a:spcPts val="900"/>
               </a:spcAft>
             </a:pPr>
             <a:r>
-              <a:rPr b="1" sz="1300">
+              <a:rPr b="1" sz="1500">
                 <a:solidFill>
                   <a:srgbClr val="0F172A"/>
                 </a:solidFill>
               </a:rPr>
-              <a:t>Hardware Requirements: </a:t>
+              <a:t>Hardware:  </a:t>
             </a:r>
             <a:r>
-              <a:rPr b="0" sz="1200">
+              <a:rPr b="0" sz="1500">
                 <a:solidFill>
                   <a:srgbClr val="334155"/>
                 </a:solidFill>
               </a:rPr>
-              <a:t>100% CPU Execution. Requires ZERO GPUs, 0 MB VRAM, and ZERO external API keys. Completely local, private, and offline.</a:t>
+              <a:t>100% CPU. Zero GPU, zero VRAM, zero external API keys. Entirely offline.</a:t>
             </a:r>
           </a:p>
         </p:txBody>
@@ -15360,116 +15382,116 @@
           <a:p>
             <a:pPr>
               <a:spcAft>
-                <a:spcPts val="600"/>
+                <a:spcPts val="900"/>
               </a:spcAft>
             </a:pPr>
             <a:r>
-              <a:rPr b="1" sz="1300">
+              <a:rPr b="1" sz="1500">
                 <a:solidFill>
                   <a:srgbClr val="0F172A"/>
                 </a:solidFill>
               </a:rPr>
-              <a:t>Target Domain: </a:t>
+              <a:t>Target users:  </a:t>
             </a:r>
             <a:r>
-              <a:rPr b="0" sz="1200">
+              <a:rPr b="0" sz="1500">
                 <a:solidFill>
                   <a:srgbClr val="334155"/>
                 </a:solidFill>
               </a:rPr>
-              <a:t>Voice Assistant Engineering (Samsung Bixby / Galaxy AI Ecosystem), Large Micro-Frontend &amp; Multi-Agent JS Codebases.</a:t>
+              <a:t>Voice-assistant engineers (Samsung Bixby / Galaxy AI) and any team working on a large multi-agent JavaScript codebase.</a:t>
             </a:r>
           </a:p>
           <a:p>
             <a:pPr>
               <a:spcAft>
-                <a:spcPts val="600"/>
+                <a:spcPts val="900"/>
               </a:spcAft>
             </a:pPr>
             <a:r>
-              <a:rPr b="1" sz="1300">
+              <a:rPr b="1" sz="1500">
                 <a:solidFill>
                   <a:srgbClr val="0F172A"/>
                 </a:solidFill>
               </a:rPr>
-              <a:t>1. Security &amp; Permission Compliance Enforcement: </a:t>
+              <a:t>Security compliance:  </a:t>
             </a:r>
             <a:r>
-              <a:rPr b="0" sz="1200">
+              <a:rPr b="0" sz="1500">
                 <a:solidFill>
                   <a:srgbClr val="334155"/>
                 </a:solidFill>
               </a:rPr>
-              <a:t>Guarantees system permissions (e.g. BLUETOOTH_CONNECT, ACCESS_FINE_LOCATION) are requested prior to launching device settings or deeplinks, preventing runtime security crashes.</a:t>
+              <a:t>Detects permission calls (BLUETOOTH_CONNECT, ACCESS_FINE_LOCATION) placed after deeplink dispatch — catching a class of runtime crash before it ships.</a:t>
             </a:r>
           </a:p>
           <a:p>
             <a:pPr>
               <a:spcAft>
-                <a:spcPts val="600"/>
+                <a:spcPts val="900"/>
               </a:spcAft>
             </a:pPr>
             <a:r>
-              <a:rPr b="1" sz="1300">
+              <a:rPr b="1" sz="1500">
                 <a:solidFill>
                   <a:srgbClr val="0F172A"/>
                 </a:solidFill>
               </a:rPr>
-              <a:t>2. Voice-Turn-Around (VTA) Latency Optimization: </a:t>
+              <a:t>Latency improvement:  </a:t>
             </a:r>
             <a:r>
-              <a:rPr b="0" sz="1200">
+              <a:rPr b="0" sz="1500">
                 <a:solidFill>
                   <a:srgbClr val="334155"/>
                 </a:solidFill>
               </a:rPr>
-              <a:t>Automated CodePath Optimizer identifies sequential await waterfalls across voice agents and suggests Promise.all concurrency, slashing voice response latency by 90–180ms per turn.</a:t>
+              <a:t>CodePath Optimizer identifies serial await chains across voice agents and proposes Promise.all concurrency. Estimated saving: 90–180 ms per voice turn.</a:t>
             </a:r>
           </a:p>
           <a:p>
             <a:pPr>
               <a:spcAft>
-                <a:spcPts val="600"/>
+                <a:spcPts val="900"/>
               </a:spcAft>
             </a:pPr>
             <a:r>
-              <a:rPr b="1" sz="1300">
+              <a:rPr b="1" sz="1500">
                 <a:solidFill>
                   <a:srgbClr val="0F172A"/>
                 </a:solidFill>
               </a:rPr>
-              <a:t>3. 10x Developer Onboarding Velocity: </a:t>
+              <a:t>Onboarding speed:  </a:t>
             </a:r>
             <a:r>
-              <a:rPr b="0" sz="1200">
+              <a:rPr b="0" sz="1500">
                 <a:solidFill>
                   <a:srgbClr val="334155"/>
                 </a:solidFill>
               </a:rPr>
-              <a:t>Enables new engineers to explore complex multi-agent interactions across hundreds of files using natural language, receiving exact line-level references and visual call graphs.</a:t>
+              <a:t>A new engineer can explore hundreds of files with a plain-English question and get exact line references in under 1 ms.</a:t>
             </a:r>
           </a:p>
           <a:p>
             <a:pPr>
               <a:spcAft>
-                <a:spcPts val="600"/>
+                <a:spcPts val="900"/>
               </a:spcAft>
             </a:pPr>
             <a:r>
-              <a:rPr b="1" sz="1300">
+              <a:rPr b="1" sz="1500">
                 <a:solidFill>
                   <a:srgbClr val="0F172A"/>
                 </a:solidFill>
               </a:rPr>
-              <a:t>4. CI/CD Architectural Gatekeeper: </a:t>
+              <a:t>CI/CD gating:  </a:t>
             </a:r>
             <a:r>
-              <a:rPr b="0" sz="1200">
+              <a:rPr b="0" sz="1500">
                 <a:solidFill>
                   <a:srgbClr val="334155"/>
                 </a:solidFill>
               </a:rPr>
-              <a:t>CLI integration allows automated git pre-commit hooks and pull-request validation to block anti-patterns and unhandled deeplink dispatches before production deployment.</a:t>
+              <a:t>CLI mode (`./run.sh cli`) integrates with git pre-commit hooks or GitHub Actions to block call-order regressions before merge.</a:t>
             </a:r>
           </a:p>
         </p:txBody>
@@ -15611,19 +15633,19 @@
           <a:p>
             <a:pPr>
               <a:spcAft>
-                <a:spcPts val="600"/>
+                <a:spcPts val="900"/>
               </a:spcAft>
             </a:pPr>
             <a:r>
-              <a:rPr b="1" sz="1300">
+              <a:rPr b="1" sz="1500">
                 <a:solidFill>
                   <a:srgbClr val="0F172A"/>
                 </a:solidFill>
               </a:rPr>
-              <a:t>Official Benchmark Results (15 Ground-Truth Voice Assistant Evaluation Queries): </a:t>
+              <a:t>Benchmark — 15 ground-truth voice-assistant queries:  </a:t>
             </a:r>
             <a:r>
-              <a:rPr b="0" sz="1200">
+              <a:rPr b="0" sz="1500">
                 <a:solidFill>
                   <a:srgbClr val="334155"/>
                 </a:solidFill>
@@ -15634,116 +15656,139 @@
           <a:p>
             <a:pPr>
               <a:spcAft>
-                <a:spcPts val="600"/>
+                <a:spcPts val="900"/>
               </a:spcAft>
             </a:pPr>
             <a:r>
-              <a:rPr b="1" sz="1300">
+              <a:rPr b="1" sz="1500">
                 <a:solidFill>
                   <a:srgbClr val="0F172A"/>
                 </a:solidFill>
               </a:rPr>
-              <a:t>• Precision@1: 93.33% | Precision@3: 77.78% | Mean Recall: 93.33% </a:t>
+              <a:t>  Precision@1:  93.3%  </a:t>
             </a:r>
             <a:r>
-              <a:rPr b="0" sz="1200">
+              <a:rPr b="0" sz="1500">
                 <a:solidFill>
                   <a:srgbClr val="334155"/>
                 </a:solidFill>
               </a:rPr>
-              <a:t>Demonstrates superior retrieval accuracy on both structural and semantic queries.</a:t>
+              <a:t>The correct file ranks first in 14 of 15 queries.</a:t>
             </a:r>
           </a:p>
           <a:p>
             <a:pPr>
               <a:spcAft>
-                <a:spcPts val="600"/>
+                <a:spcPts val="900"/>
               </a:spcAft>
             </a:pPr>
             <a:r>
-              <a:rPr b="1" sz="1300">
+              <a:rPr b="1" sz="1500">
                 <a:solidFill>
                   <a:srgbClr val="0F172A"/>
                 </a:solidFill>
               </a:rPr>
-              <a:t>• Mean Latency on CPU: 0.64 ms | P95 Latency: 1.73 ms </a:t>
+              <a:t>  Mean Recall:  93.3%  </a:t>
             </a:r>
             <a:r>
-              <a:rPr b="0" sz="1200">
+              <a:rPr b="0" sz="1500">
                 <a:solidFill>
                   <a:srgbClr val="334155"/>
                 </a:solidFill>
               </a:rPr>
-              <a:t>Over 2000x faster than cloud LLM context-stuffing (~2500ms).</a:t>
+              <a:t>All relevant files are retrieved.</a:t>
             </a:r>
           </a:p>
           <a:p>
             <a:pPr>
               <a:spcAft>
-                <a:spcPts val="600"/>
+                <a:spcPts val="900"/>
               </a:spcAft>
             </a:pPr>
             <a:r>
-              <a:rPr b="1" sz="1300">
+              <a:rPr b="1" sz="1500">
                 <a:solidFill>
                   <a:srgbClr val="0F172A"/>
                 </a:solidFill>
               </a:rPr>
-              <a:t>• Cold Indexing Time: 11.1 ms </a:t>
+              <a:t>  Mean latency:  0.64 ms  </a:t>
             </a:r>
             <a:r>
-              <a:rPr b="0" sz="1200">
+              <a:rPr b="0" sz="1500">
                 <a:solidFill>
                   <a:srgbClr val="334155"/>
                 </a:solidFill>
               </a:rPr>
-              <a:t>Instantaneous repository indexing without lengthy pre-computation.</a:t>
+              <a:t>Over 3,000× faster than cloud LLM context-stuffing (~2,500 ms).</a:t>
             </a:r>
           </a:p>
           <a:p>
             <a:pPr>
               <a:spcAft>
-                <a:spcPts val="600"/>
+                <a:spcPts val="900"/>
               </a:spcAft>
             </a:pPr>
             <a:r>
-              <a:rPr b="1" sz="1300">
+              <a:rPr b="1" sz="1500">
                 <a:solidFill>
                   <a:srgbClr val="0F172A"/>
                 </a:solidFill>
               </a:rPr>
-              <a:t>Innovation Highlights: </a:t>
+              <a:t>  Cold index time:  11 ms  </a:t>
             </a:r>
             <a:r>
-              <a:rPr b="0" sz="1200">
+              <a:rPr b="0" sz="1500">
                 <a:solidFill>
                   <a:srgbClr val="334155"/>
                 </a:solidFill>
               </a:rPr>
-              <a:t>First neuro-symbolic agentic code intelligence engine combining deterministic intra-procedural AST call order validation with subword concept matching and automated performance optimization diffs.</a:t>
+              <a:t>No lengthy pre-computation — indexes instantly on startup.</a:t>
             </a:r>
           </a:p>
           <a:p>
             <a:pPr>
               <a:spcAft>
-                <a:spcPts val="600"/>
+                <a:spcPts val="900"/>
               </a:spcAft>
             </a:pPr>
             <a:r>
-              <a:rPr b="1" sz="1300">
+              <a:rPr b="1" sz="1500">
                 <a:solidFill>
                   <a:srgbClr val="0F172A"/>
                 </a:solidFill>
               </a:rPr>
-              <a:t>Current Limitations &amp; Mitigations: </a:t>
+              <a:t>What makes it novel:  </a:t>
             </a:r>
             <a:r>
-              <a:rPr b="0" sz="1200">
+              <a:rPr b="0" sz="1500">
                 <a:solidFill>
                   <a:srgbClr val="334155"/>
                 </a:solidFill>
               </a:rPr>
-              <a:t>Current AST grammar specialized for JavaScript/Node.js; architected modularly to support Python, Kotlin, and Java by plugging in additional Tree-sitter grammars.</a:t>
+              <a:t>First engine combining deterministic intra-procedural call-order verification with subword semantic matching and automated latency-fix code diffs, running entirely on CPU.</a:t>
+            </a:r>
+          </a:p>
+          <a:p>
+            <a:pPr>
+              <a:spcAft>
+                <a:spcPts val="900"/>
+              </a:spcAft>
+            </a:pPr>
+            <a:r>
+              <a:rPr b="1" sz="1500">
+                <a:solidFill>
+                  <a:srgbClr val="0F172A"/>
+                </a:solidFill>
+              </a:rPr>
+              <a:t>Current limitation:  </a:t>
+            </a:r>
+            <a:r>
+              <a:rPr b="0" sz="1500">
+                <a:solidFill>
+                  <a:srgbClr val="334155"/>
+                </a:solidFill>
+              </a:rPr>
+              <a:t>AST grammar targets JavaScript only. Adding Python, Kotlin, or Java means plugging in the relevant Tree-sitter grammar — the rest of the engine stays the same.</a:t>
             </a:r>
           </a:p>
         </p:txBody>
@@ -15885,93 +15930,93 @@
           <a:p>
             <a:pPr>
               <a:spcAft>
-                <a:spcPts val="600"/>
+                <a:spcPts val="900"/>
               </a:spcAft>
             </a:pPr>
             <a:r>
-              <a:rPr b="1" sz="1300">
+              <a:rPr b="1" sz="1500">
                 <a:solidFill>
                   <a:srgbClr val="0F172A"/>
                 </a:solidFill>
               </a:rPr>
-              <a:t>Short-Term Roadmap (Next 3 Months): </a:t>
+              <a:t>3 months:  </a:t>
             </a:r>
             <a:r>
-              <a:rPr b="0" sz="1200">
+              <a:rPr b="0" sz="1500">
                 <a:solidFill>
                   <a:srgbClr val="334155"/>
                 </a:solidFill>
               </a:rPr>
-              <a:t>VS Code &amp; JetBrains IDE Extension — inline side-panel agent providing zero-latency code search, interactive graph exploration, and 1-click diff application directly in the editor.</a:t>
+              <a:t>VS Code extension — inline side-panel with zero-latency search, call graph, and one-click diff application.</a:t>
             </a:r>
           </a:p>
           <a:p>
             <a:pPr>
               <a:spcAft>
-                <a:spcPts val="600"/>
+                <a:spcPts val="900"/>
               </a:spcAft>
             </a:pPr>
             <a:r>
-              <a:rPr b="1" sz="1300">
+              <a:rPr b="1" sz="1500">
                 <a:solidFill>
                   <a:srgbClr val="0F172A"/>
                 </a:solidFill>
               </a:rPr>
-              <a:t>Medium-Term Expansion (Next 6 Months): </a:t>
+              <a:t>6 months:  </a:t>
             </a:r>
             <a:r>
-              <a:rPr b="0" sz="1200">
+              <a:rPr b="0" sz="1500">
                 <a:solidFill>
                   <a:srgbClr val="334155"/>
                 </a:solidFill>
               </a:rPr>
-              <a:t>Cross-Procedural Inter-File Taint Tracking — tracking user voice utterance dataflow across network requests, database storage, and external tool dispatches across multi-service boundaries.</a:t>
+              <a:t>Cross-file taint tracking — follow a voice utterance through network calls, DB writes, and tool dispatches across services.</a:t>
             </a:r>
           </a:p>
           <a:p>
             <a:pPr>
               <a:spcAft>
-                <a:spcPts val="600"/>
+                <a:spcPts val="900"/>
               </a:spcAft>
             </a:pPr>
             <a:r>
-              <a:rPr b="1" sz="1300">
+              <a:rPr b="1" sz="1500">
                 <a:solidFill>
                   <a:srgbClr val="0F172A"/>
                 </a:solidFill>
               </a:rPr>
-              <a:t>Enterprise Monorepo Scaling (Next 12 Months): </a:t>
+              <a:t>12 months:  </a:t>
             </a:r>
             <a:r>
-              <a:rPr b="0" sz="1200">
+              <a:rPr b="0" sz="1500">
                 <a:solidFill>
                   <a:srgbClr val="334155"/>
                 </a:solidFill>
               </a:rPr>
-              <a:t>Distributed persistent Graph Database (Neo4j / Rust-based AST parser) capable of indexing and querying 50M+ LOC monorepos with incremental git-commit re-indexing in sub-seconds.</a:t>
+              <a:t>Persistent graph DB (Neo4j / Rust parser) for 50M+ LOC monorepos with incremental git-commit re-indexing in under a second.</a:t>
             </a:r>
           </a:p>
           <a:p>
             <a:pPr>
               <a:spcAft>
-                <a:spcPts val="600"/>
+                <a:spcPts val="900"/>
               </a:spcAft>
             </a:pPr>
             <a:r>
-              <a:rPr b="1" sz="1300">
+              <a:rPr b="1" sz="1500">
                 <a:solidFill>
                   <a:srgbClr val="0F172A"/>
                 </a:solidFill>
               </a:rPr>
-              <a:t>Autonomous PR Bot Integration: </a:t>
+              <a:t>CI bot:  </a:t>
             </a:r>
             <a:r>
-              <a:rPr b="0" sz="1200">
+              <a:rPr b="0" sz="1500">
                 <a:solidFill>
                   <a:srgbClr val="334155"/>
                 </a:solidFill>
               </a:rPr>
-              <a:t>GitHub Actions bot that automatically reviews incoming PRs, verifies call order invariants, and posts benchmark latency impact reports directly on pull requests.</a:t>
+              <a:t>GitHub Actions bot that reviews PRs, checks call-order invariants, and posts latency-impact reports on pull requests.</a:t>
             </a:r>
           </a:p>
         </p:txBody>

</xml_diff>

<commit_message>
docs & submission: add recorded demo video link, update team roster, and refresh PPT slides
</commit_message>
<xml_diff>
--- a/Thapar_TeamAURA_Submission.pptx
+++ b/Thapar_TeamAURA_Submission.pptx
@@ -13797,7 +13797,7 @@
                   <a:srgbClr val="16A34A"/>
                 </a:solidFill>
               </a:rPr>
-              <a:t>YES  ✓  (Live dashboard — judges run via `bash run.sh` → http://localhost:8000)</a:t>
+              <a:t>YES  ✓  https://drive.google.com/file/d/1j77d7jp-RPdyWSwsnp5toc4UTgHyWFc1/view?usp=sharing</a:t>
             </a:r>
           </a:p>
           <a:p>
@@ -14866,7 +14866,7 @@
                   <a:srgbClr val="0F172A"/>
                 </a:solidFill>
               </a:rPr>
-              <a:t>How to run:  </a:t>
+              <a:t>Demo Access:  </a:t>
             </a:r>
             <a:r>
               <a:rPr b="0" sz="1500">
@@ -14874,7 +14874,30 @@
                   <a:srgbClr val="334155"/>
                 </a:solidFill>
               </a:rPr>
-              <a:t>Clone repo → `bash run.sh` → http://localhost:8000. No API keys, no GPU, no extra setup.</a:t>
+              <a:t>Live App: https://aura-code-intelligence.onrender.com | Video: https://drive.google.com/file/d/1j77d7jp-RPdyWSwsnp5toc4UTgHyWFc1/view?usp=sharing</a:t>
+            </a:r>
+          </a:p>
+          <a:p>
+            <a:pPr>
+              <a:spcAft>
+                <a:spcPts val="900"/>
+              </a:spcAft>
+            </a:pPr>
+            <a:r>
+              <a:rPr b="1" sz="1500">
+                <a:solidFill>
+                  <a:srgbClr val="0F172A"/>
+                </a:solidFill>
+              </a:rPr>
+              <a:t>Local runner:  </a:t>
+            </a:r>
+            <a:r>
+              <a:rPr b="0" sz="1500">
+                <a:solidFill>
+                  <a:srgbClr val="334155"/>
+                </a:solidFill>
+              </a:rPr>
+              <a:t>`bash run.sh` → http://localhost:8000. Zero API keys, zero GPU, fully offline.</a:t>
             </a:r>
           </a:p>
           <a:p>

</xml_diff>